<commit_message>
feat: add video demo modal and presentation updates
- Implement `VideoPlayerModal` and integrate into the main header
- Configure Vite middleware to serve demonstration video and PPTX files
- Update presentation deck with new performance benchmark slides and enhanced hero visuals
</commit_message>
<xml_diff>
--- a/public/SafeStack_Weather_Guard_Presentation.pptx
+++ b/public/SafeStack_Weather_Guard_Presentation.pptx
@@ -2032,32 +2032,56 @@
           <a:chExt cx="0" cy="0"/>
         </a:xfrm>
       </p:grpSpPr>
-      <p:sp>
-        <p:nvSpPr>
-          <p:cNvPr id="2" name="Text 0"/>
-          <p:cNvSpPr/>
-          <p:nvPr/>
-        </p:nvSpPr>
-        <p:spPr>
-          <a:xfrm>
-            <a:off x="731520" y="1371600"/>
-            <a:ext cx="10058400" cy="365760"/>
-          </a:xfrm>
-          <a:prstGeom prst="rect">
-            <a:avLst/>
-          </a:prstGeom>
-          <a:noFill/>
-          <a:ln/>
-        </p:spPr>
-        <p:txBody>
-          <a:bodyPr wrap="square" rtlCol="0" anchor="ctr"/>
-          <a:lstStyle/>
-          <a:p>
-            <a:pPr indent="0" marL="0">
-              <a:buNone/>
-            </a:pPr>
-            <a:r>
-              <a:rPr lang="en-US" sz="1400" b="1" dirty="0">
+      <p:pic>
+        <p:nvPicPr>
+          <p:cNvPr id="2" name="Image 0" descr="/app/applet/src/assets/images/construction_safety_hero_1792117992203.jpg">    </p:cNvPr>
+          <p:cNvPicPr>
+            <a:picLocks noChangeAspect="1"/>
+          </p:cNvPicPr>
+          <p:nvPr/>
+        </p:nvPicPr>
+        <p:blipFill>
+          <a:blip r:embed="rId1"/>
+          <a:stretch>
+            <a:fillRect/>
+          </a:stretch>
+        </p:blipFill>
+        <p:spPr>
+          <a:xfrm>
+            <a:off x="6583680" y="731520"/>
+            <a:ext cx="4846320" cy="3108960"/>
+          </a:xfrm>
+          <a:prstGeom prst="ellipse">
+            <a:avLst/>
+          </a:prstGeom>
+        </p:spPr>
+      </p:pic>
+      <p:sp>
+        <p:nvSpPr>
+          <p:cNvPr id="3" name="Text 0"/>
+          <p:cNvSpPr/>
+          <p:nvPr/>
+        </p:nvSpPr>
+        <p:spPr>
+          <a:xfrm>
+            <a:off x="731520" y="731520"/>
+            <a:ext cx="5669280" cy="320040"/>
+          </a:xfrm>
+          <a:prstGeom prst="rect">
+            <a:avLst/>
+          </a:prstGeom>
+          <a:noFill/>
+          <a:ln/>
+        </p:spPr>
+        <p:txBody>
+          <a:bodyPr wrap="square" rtlCol="0" anchor="ctr"/>
+          <a:lstStyle/>
+          <a:p>
+            <a:pPr indent="0" marL="0">
+              <a:buNone/>
+            </a:pPr>
+            <a:r>
+              <a:rPr lang="en-US" sz="1200" b="1" dirty="0">
                 <a:solidFill>
                   <a:srgbClr val="F59E0B"/>
                 </a:solidFill>
@@ -2067,36 +2091,36 @@
               </a:rPr>
               <a:t>AUTONOMOUS AERODYNAMIC RISK MANAGEMENT</a:t>
             </a:r>
-            <a:endParaRPr lang="en-US" sz="1400" dirty="0"/>
-          </a:p>
-        </p:txBody>
-      </p:sp>
-      <p:sp>
-        <p:nvSpPr>
-          <p:cNvPr id="3" name="Text 1"/>
-          <p:cNvSpPr/>
-          <p:nvPr/>
-        </p:nvSpPr>
-        <p:spPr>
-          <a:xfrm>
-            <a:off x="731520" y="1828800"/>
-            <a:ext cx="10515600" cy="1097280"/>
-          </a:xfrm>
-          <a:prstGeom prst="rect">
-            <a:avLst/>
-          </a:prstGeom>
-          <a:noFill/>
-          <a:ln/>
-        </p:spPr>
-        <p:txBody>
-          <a:bodyPr wrap="square" rtlCol="0" anchor="ctr"/>
-          <a:lstStyle/>
-          <a:p>
-            <a:pPr indent="0" marL="0">
-              <a:buNone/>
-            </a:pPr>
-            <a:r>
-              <a:rPr lang="en-US" sz="4400" b="1" dirty="0">
+            <a:endParaRPr lang="en-US" sz="1200" dirty="0"/>
+          </a:p>
+        </p:txBody>
+      </p:sp>
+      <p:sp>
+        <p:nvSpPr>
+          <p:cNvPr id="4" name="Text 1"/>
+          <p:cNvSpPr/>
+          <p:nvPr/>
+        </p:nvSpPr>
+        <p:spPr>
+          <a:xfrm>
+            <a:off x="731520" y="1097280"/>
+            <a:ext cx="5669280" cy="1097280"/>
+          </a:xfrm>
+          <a:prstGeom prst="rect">
+            <a:avLst/>
+          </a:prstGeom>
+          <a:noFill/>
+          <a:ln/>
+        </p:spPr>
+        <p:txBody>
+          <a:bodyPr wrap="square" rtlCol="0" anchor="ctr"/>
+          <a:lstStyle/>
+          <a:p>
+            <a:pPr indent="0" marL="0">
+              <a:buNone/>
+            </a:pPr>
+            <a:r>
+              <a:rPr lang="en-US" sz="3600" b="1" dirty="0">
                 <a:solidFill>
                   <a:srgbClr val="F8FAFC"/>
                 </a:solidFill>
@@ -2106,36 +2130,36 @@
               </a:rPr>
               <a:t>SafeStack Weather Guard</a:t>
             </a:r>
-            <a:endParaRPr lang="en-US" sz="4400" dirty="0"/>
-          </a:p>
-        </p:txBody>
-      </p:sp>
-      <p:sp>
-        <p:nvSpPr>
-          <p:cNvPr id="4" name="Text 2"/>
-          <p:cNvSpPr/>
-          <p:nvPr/>
-        </p:nvSpPr>
-        <p:spPr>
-          <a:xfrm>
-            <a:off x="731520" y="3017520"/>
-            <a:ext cx="10058400" cy="548640"/>
-          </a:xfrm>
-          <a:prstGeom prst="rect">
-            <a:avLst/>
-          </a:prstGeom>
-          <a:noFill/>
-          <a:ln/>
-        </p:spPr>
-        <p:txBody>
-          <a:bodyPr wrap="square" rtlCol="0" anchor="ctr"/>
-          <a:lstStyle/>
-          <a:p>
-            <a:pPr indent="0" marL="0">
-              <a:buNone/>
-            </a:pPr>
-            <a:r>
-              <a:rPr lang="en-US" sz="1800" dirty="0">
+            <a:endParaRPr lang="en-US" sz="3600" dirty="0"/>
+          </a:p>
+        </p:txBody>
+      </p:sp>
+      <p:sp>
+        <p:nvSpPr>
+          <p:cNvPr id="5" name="Text 2"/>
+          <p:cNvSpPr/>
+          <p:nvPr/>
+        </p:nvSpPr>
+        <p:spPr>
+          <a:xfrm>
+            <a:off x="731520" y="2286000"/>
+            <a:ext cx="5669280" cy="731520"/>
+          </a:xfrm>
+          <a:prstGeom prst="rect">
+            <a:avLst/>
+          </a:prstGeom>
+          <a:noFill/>
+          <a:ln/>
+        </p:spPr>
+        <p:txBody>
+          <a:bodyPr wrap="square" rtlCol="0" anchor="ctr"/>
+          <a:lstStyle/>
+          <a:p>
+            <a:pPr indent="0" marL="0">
+              <a:buNone/>
+            </a:pPr>
+            <a:r>
+              <a:rPr lang="en-US" sz="1500" dirty="0">
                 <a:solidFill>
                   <a:srgbClr val="94A3B8"/>
                 </a:solidFill>
@@ -2145,24 +2169,24 @@
               </a:rPr>
               <a:t>Real-Time Construction Yard Aerodynamic Safety &amp; Dynamic Weather Risk Intelligence Platform</a:t>
             </a:r>
-            <a:endParaRPr lang="en-US" sz="1800" dirty="0"/>
-          </a:p>
-        </p:txBody>
-      </p:sp>
-      <p:sp>
-        <p:nvSpPr>
-          <p:cNvPr id="5" name="Shape 3"/>
-          <p:cNvSpPr/>
-          <p:nvPr/>
-        </p:nvSpPr>
-        <p:spPr>
-          <a:xfrm>
-            <a:off x="731520" y="4023360"/>
-            <a:ext cx="3291840" cy="1645920"/>
+            <a:endParaRPr lang="en-US" sz="1500" dirty="0"/>
+          </a:p>
+        </p:txBody>
+      </p:sp>
+      <p:sp>
+        <p:nvSpPr>
+          <p:cNvPr id="6" name="Shape 3"/>
+          <p:cNvSpPr/>
+          <p:nvPr/>
+        </p:nvSpPr>
+        <p:spPr>
+          <a:xfrm>
+            <a:off x="731520" y="4114800"/>
+            <a:ext cx="3291840" cy="1920240"/>
           </a:xfrm>
           <a:prstGeom prst="roundRect">
             <a:avLst>
-              <a:gd name="adj" fmla="val 5556"/>
+              <a:gd name="adj" fmla="val 4762"/>
             </a:avLst>
           </a:prstGeom>
           <a:solidFill>
@@ -2178,30 +2202,30 @@
       </p:sp>
       <p:sp>
         <p:nvSpPr>
-          <p:cNvPr id="6" name="Text 4"/>
-          <p:cNvSpPr/>
-          <p:nvPr/>
-        </p:nvSpPr>
-        <p:spPr>
-          <a:xfrm>
-            <a:off x="914400" y="4206240"/>
-            <a:ext cx="2926080" cy="1280160"/>
-          </a:xfrm>
-          <a:prstGeom prst="rect">
-            <a:avLst/>
-          </a:prstGeom>
-          <a:noFill/>
-          <a:ln/>
-        </p:spPr>
-        <p:txBody>
-          <a:bodyPr wrap="square" rtlCol="0" anchor="ctr"/>
-          <a:lstStyle/>
-          <a:p>
-            <a:pPr indent="0" marL="0">
-              <a:buNone/>
-            </a:pPr>
-            <a:r>
-              <a:rPr lang="en-US" sz="1200" dirty="0">
+          <p:cNvPr id="7" name="Text 4"/>
+          <p:cNvSpPr/>
+          <p:nvPr/>
+        </p:nvSpPr>
+        <p:spPr>
+          <a:xfrm>
+            <a:off x="914400" y="4297680"/>
+            <a:ext cx="2926080" cy="1554480"/>
+          </a:xfrm>
+          <a:prstGeom prst="rect">
+            <a:avLst/>
+          </a:prstGeom>
+          <a:noFill/>
+          <a:ln/>
+        </p:spPr>
+        <p:txBody>
+          <a:bodyPr wrap="square" rtlCol="0" anchor="ctr"/>
+          <a:lstStyle/>
+          <a:p>
+            <a:pPr indent="0" marL="0">
+              <a:buNone/>
+            </a:pPr>
+            <a:r>
+              <a:rPr lang="en-US" sz="1100" dirty="0">
                 <a:solidFill>
                   <a:srgbClr val="F8FAFC"/>
                 </a:solidFill>
@@ -2211,14 +2235,14 @@
               </a:rPr>
               <a:t>LIVE WEATHER PIPELINE</a:t>
             </a:r>
-            <a:endParaRPr lang="en-US" sz="1200" dirty="0"/>
-          </a:p>
-          <a:p>
-            <a:pPr indent="0" marL="0">
-              <a:buNone/>
-            </a:pPr>
-            <a:r>
-              <a:rPr lang="en-US" sz="1200" dirty="0">
+            <a:endParaRPr lang="en-US" sz="1100" dirty="0"/>
+          </a:p>
+          <a:p>
+            <a:pPr indent="0" marL="0">
+              <a:buNone/>
+            </a:pPr>
+            <a:r>
+              <a:rPr lang="en-US" sz="1100" dirty="0">
                 <a:solidFill>
                   <a:srgbClr val="F8FAFC"/>
                 </a:solidFill>
@@ -2228,14 +2252,14 @@
               </a:rPr>
               <a:t>KMA Ultra-Short-Term API</a:t>
             </a:r>
-            <a:endParaRPr lang="en-US" sz="1200" dirty="0"/>
-          </a:p>
-          <a:p>
-            <a:pPr indent="0" marL="0">
-              <a:buNone/>
-            </a:pPr>
-            <a:r>
-              <a:rPr lang="en-US" sz="1200" dirty="0">
+            <a:endParaRPr lang="en-US" sz="1100" dirty="0"/>
+          </a:p>
+          <a:p>
+            <a:pPr indent="0" marL="0">
+              <a:buNone/>
+            </a:pPr>
+            <a:r>
+              <a:rPr lang="en-US" sz="1100" dirty="0">
                 <a:solidFill>
                   <a:srgbClr val="F8FAFC"/>
                 </a:solidFill>
@@ -2245,14 +2269,14 @@
               </a:rPr>
               <a:t>24-Hour Predictive Gust Models</a:t>
             </a:r>
-            <a:endParaRPr lang="en-US" sz="1200" dirty="0"/>
-          </a:p>
-          <a:p>
-            <a:pPr indent="0" marL="0">
-              <a:buNone/>
-            </a:pPr>
-            <a:r>
-              <a:rPr lang="en-US" sz="1200" dirty="0">
+            <a:endParaRPr lang="en-US" sz="1100" dirty="0"/>
+          </a:p>
+          <a:p>
+            <a:pPr indent="0" marL="0">
+              <a:buNone/>
+            </a:pPr>
+            <a:r>
+              <a:rPr lang="en-US" sz="1100" dirty="0">
                 <a:solidFill>
                   <a:srgbClr val="F8FAFC"/>
                 </a:solidFill>
@@ -2262,24 +2286,24 @@
               </a:rPr>
               <a:t>GPS Multi-Hub Site Switching</a:t>
             </a:r>
-            <a:endParaRPr lang="en-US" sz="1200" dirty="0"/>
-          </a:p>
-        </p:txBody>
-      </p:sp>
-      <p:sp>
-        <p:nvSpPr>
-          <p:cNvPr id="7" name="Shape 5"/>
-          <p:cNvSpPr/>
-          <p:nvPr/>
-        </p:nvSpPr>
-        <p:spPr>
-          <a:xfrm>
-            <a:off x="4297680" y="4023360"/>
-            <a:ext cx="3291840" cy="1645920"/>
+            <a:endParaRPr lang="en-US" sz="1100" dirty="0"/>
+          </a:p>
+        </p:txBody>
+      </p:sp>
+      <p:sp>
+        <p:nvSpPr>
+          <p:cNvPr id="8" name="Shape 5"/>
+          <p:cNvSpPr/>
+          <p:nvPr/>
+        </p:nvSpPr>
+        <p:spPr>
+          <a:xfrm>
+            <a:off x="4297680" y="4114800"/>
+            <a:ext cx="3291840" cy="1920240"/>
           </a:xfrm>
           <a:prstGeom prst="roundRect">
             <a:avLst>
-              <a:gd name="adj" fmla="val 5556"/>
+              <a:gd name="adj" fmla="val 4762"/>
             </a:avLst>
           </a:prstGeom>
           <a:solidFill>
@@ -2295,30 +2319,30 @@
       </p:sp>
       <p:sp>
         <p:nvSpPr>
-          <p:cNvPr id="8" name="Text 6"/>
-          <p:cNvSpPr/>
-          <p:nvPr/>
-        </p:nvSpPr>
-        <p:spPr>
-          <a:xfrm>
-            <a:off x="4480560" y="4206240"/>
-            <a:ext cx="2926080" cy="1280160"/>
-          </a:xfrm>
-          <a:prstGeom prst="rect">
-            <a:avLst/>
-          </a:prstGeom>
-          <a:noFill/>
-          <a:ln/>
-        </p:spPr>
-        <p:txBody>
-          <a:bodyPr wrap="square" rtlCol="0" anchor="ctr"/>
-          <a:lstStyle/>
-          <a:p>
-            <a:pPr indent="0" marL="0">
-              <a:buNone/>
-            </a:pPr>
-            <a:r>
-              <a:rPr lang="en-US" sz="1200" dirty="0">
+          <p:cNvPr id="9" name="Text 6"/>
+          <p:cNvSpPr/>
+          <p:nvPr/>
+        </p:nvSpPr>
+        <p:spPr>
+          <a:xfrm>
+            <a:off x="4480560" y="4297680"/>
+            <a:ext cx="2926080" cy="1554480"/>
+          </a:xfrm>
+          <a:prstGeom prst="rect">
+            <a:avLst/>
+          </a:prstGeom>
+          <a:noFill/>
+          <a:ln/>
+        </p:spPr>
+        <p:txBody>
+          <a:bodyPr wrap="square" rtlCol="0" anchor="ctr"/>
+          <a:lstStyle/>
+          <a:p>
+            <a:pPr indent="0" marL="0">
+              <a:buNone/>
+            </a:pPr>
+            <a:r>
+              <a:rPr lang="en-US" sz="1100" dirty="0">
                 <a:solidFill>
                   <a:srgbClr val="F8FAFC"/>
                 </a:solidFill>
@@ -2328,14 +2352,14 @@
               </a:rPr>
               <a:t>5 PHYSICS RISK ENGINES</a:t>
             </a:r>
-            <a:endParaRPr lang="en-US" sz="1200" dirty="0"/>
-          </a:p>
-          <a:p>
-            <a:pPr indent="0" marL="0">
-              <a:buNone/>
-            </a:pPr>
-            <a:r>
-              <a:rPr lang="en-US" sz="1200" dirty="0">
+            <a:endParaRPr lang="en-US" sz="1100" dirty="0"/>
+          </a:p>
+          <a:p>
+            <a:pPr indent="0" marL="0">
+              <a:buNone/>
+            </a:pPr>
+            <a:r>
+              <a:rPr lang="en-US" sz="1100" dirty="0">
                 <a:solidFill>
                   <a:srgbClr val="F8FAFC"/>
                 </a:solidFill>
@@ -2345,14 +2369,14 @@
               </a:rPr>
               <a:t>NASA Aerodynamic Drag &amp; Lift</a:t>
             </a:r>
-            <a:endParaRPr lang="en-US" sz="1200" dirty="0"/>
-          </a:p>
-          <a:p>
-            <a:pPr indent="0" marL="0">
-              <a:buNone/>
-            </a:pPr>
-            <a:r>
-              <a:rPr lang="en-US" sz="1200" dirty="0">
+            <a:endParaRPr lang="en-US" sz="1100" dirty="0"/>
+          </a:p>
+          <a:p>
+            <a:pPr indent="0" marL="0">
+              <a:buNone/>
+            </a:pPr>
+            <a:r>
+              <a:rPr lang="en-US" sz="1100" dirty="0">
                 <a:solidFill>
                   <a:srgbClr val="F8FAFC"/>
                 </a:solidFill>
@@ -2362,14 +2386,14 @@
               </a:rPr>
               <a:t>Sliding, Toppling &amp; Uplift FS</a:t>
             </a:r>
-            <a:endParaRPr lang="en-US" sz="1200" dirty="0"/>
-          </a:p>
-          <a:p>
-            <a:pPr indent="0" marL="0">
-              <a:buNone/>
-            </a:pPr>
-            <a:r>
-              <a:rPr lang="en-US" sz="1200" dirty="0">
+            <a:endParaRPr lang="en-US" sz="1100" dirty="0"/>
+          </a:p>
+          <a:p>
+            <a:pPr indent="0" marL="0">
+              <a:buNone/>
+            </a:pPr>
+            <a:r>
+              <a:rPr lang="en-US" sz="1100" dirty="0">
                 <a:solidFill>
                   <a:srgbClr val="F8FAFC"/>
                 </a:solidFill>
@@ -2379,24 +2403,24 @@
               </a:rPr>
               <a:t>Dual-Height Edge Fall Protection</a:t>
             </a:r>
-            <a:endParaRPr lang="en-US" sz="1200" dirty="0"/>
-          </a:p>
-        </p:txBody>
-      </p:sp>
-      <p:sp>
-        <p:nvSpPr>
-          <p:cNvPr id="9" name="Shape 7"/>
-          <p:cNvSpPr/>
-          <p:nvPr/>
-        </p:nvSpPr>
-        <p:spPr>
-          <a:xfrm>
-            <a:off x="7863840" y="4023360"/>
-            <a:ext cx="3291840" cy="1645920"/>
+            <a:endParaRPr lang="en-US" sz="1100" dirty="0"/>
+          </a:p>
+        </p:txBody>
+      </p:sp>
+      <p:sp>
+        <p:nvSpPr>
+          <p:cNvPr id="10" name="Shape 7"/>
+          <p:cNvSpPr/>
+          <p:nvPr/>
+        </p:nvSpPr>
+        <p:spPr>
+          <a:xfrm>
+            <a:off x="7863840" y="4114800"/>
+            <a:ext cx="3566160" cy="1920240"/>
           </a:xfrm>
           <a:prstGeom prst="roundRect">
             <a:avLst>
-              <a:gd name="adj" fmla="val 5556"/>
+              <a:gd name="adj" fmla="val 4762"/>
             </a:avLst>
           </a:prstGeom>
           <a:solidFill>
@@ -2412,30 +2436,30 @@
       </p:sp>
       <p:sp>
         <p:nvSpPr>
-          <p:cNvPr id="10" name="Text 8"/>
-          <p:cNvSpPr/>
-          <p:nvPr/>
-        </p:nvSpPr>
-        <p:spPr>
-          <a:xfrm>
-            <a:off x="8046720" y="4206240"/>
-            <a:ext cx="2926080" cy="1280160"/>
-          </a:xfrm>
-          <a:prstGeom prst="rect">
-            <a:avLst/>
-          </a:prstGeom>
-          <a:noFill/>
-          <a:ln/>
-        </p:spPr>
-        <p:txBody>
-          <a:bodyPr wrap="square" rtlCol="0" anchor="ctr"/>
-          <a:lstStyle/>
-          <a:p>
-            <a:pPr indent="0" marL="0">
-              <a:buNone/>
-            </a:pPr>
-            <a:r>
-              <a:rPr lang="en-US" sz="1200" dirty="0">
+          <p:cNvPr id="11" name="Text 8"/>
+          <p:cNvSpPr/>
+          <p:nvPr/>
+        </p:nvSpPr>
+        <p:spPr>
+          <a:xfrm>
+            <a:off x="8046720" y="4297680"/>
+            <a:ext cx="3200400" cy="1554480"/>
+          </a:xfrm>
+          <a:prstGeom prst="rect">
+            <a:avLst/>
+          </a:prstGeom>
+          <a:noFill/>
+          <a:ln/>
+        </p:spPr>
+        <p:txBody>
+          <a:bodyPr wrap="square" rtlCol="0" anchor="ctr"/>
+          <a:lstStyle/>
+          <a:p>
+            <a:pPr indent="0" marL="0">
+              <a:buNone/>
+            </a:pPr>
+            <a:r>
+              <a:rPr lang="en-US" sz="1100" dirty="0">
                 <a:solidFill>
                   <a:srgbClr val="F8FAFC"/>
                 </a:solidFill>
@@ -2445,14 +2469,14 @@
               </a:rPr>
               <a:t>MOBILE PATROL &amp; AI</a:t>
             </a:r>
-            <a:endParaRPr lang="en-US" sz="1200" dirty="0"/>
-          </a:p>
-          <a:p>
-            <a:pPr indent="0" marL="0">
-              <a:buNone/>
-            </a:pPr>
-            <a:r>
-              <a:rPr lang="en-US" sz="1200" dirty="0">
+            <a:endParaRPr lang="en-US" sz="1100" dirty="0"/>
+          </a:p>
+          <a:p>
+            <a:pPr indent="0" marL="0">
+              <a:buNone/>
+            </a:pPr>
+            <a:r>
+              <a:rPr lang="en-US" sz="1100" dirty="0">
                 <a:solidFill>
                   <a:srgbClr val="F8FAFC"/>
                 </a:solidFill>
@@ -2462,14 +2486,14 @@
               </a:rPr>
               <a:t>Gemini 3.8 Flash Vision Intake</a:t>
             </a:r>
-            <a:endParaRPr lang="en-US" sz="1200" dirty="0"/>
-          </a:p>
-          <a:p>
-            <a:pPr indent="0" marL="0">
-              <a:buNone/>
-            </a:pPr>
-            <a:r>
-              <a:rPr lang="en-US" sz="1200" dirty="0">
+            <a:endParaRPr lang="en-US" sz="1100" dirty="0"/>
+          </a:p>
+          <a:p>
+            <a:pPr indent="0" marL="0">
+              <a:buNone/>
+            </a:pPr>
+            <a:r>
+              <a:rPr lang="en-US" sz="1100" dirty="0">
                 <a:solidFill>
                   <a:srgbClr val="F8FAFC"/>
                 </a:solidFill>
@@ -2479,14 +2503,14 @@
               </a:rPr>
               <a:t>Sub-Second Camera QR Decoding</a:t>
             </a:r>
-            <a:endParaRPr lang="en-US" sz="1200" dirty="0"/>
-          </a:p>
-          <a:p>
-            <a:pPr indent="0" marL="0">
-              <a:buNone/>
-            </a:pPr>
-            <a:r>
-              <a:rPr lang="en-US" sz="1200" dirty="0">
+            <a:endParaRPr lang="en-US" sz="1100" dirty="0"/>
+          </a:p>
+          <a:p>
+            <a:pPr indent="0" marL="0">
+              <a:buNone/>
+            </a:pPr>
+            <a:r>
+              <a:rPr lang="en-US" sz="1100" dirty="0">
                 <a:solidFill>
                   <a:srgbClr val="F8FAFC"/>
                 </a:solidFill>
@@ -2496,7 +2520,7 @@
               </a:rPr>
               <a:t>5-Entry Safety Audit Trail</a:t>
             </a:r>
-            <a:endParaRPr lang="en-US" sz="1200" dirty="0"/>
+            <a:endParaRPr lang="en-US" sz="1100" dirty="0"/>
           </a:p>
         </p:txBody>
       </p:sp>
@@ -3186,178 +3210,33 @@
           </a:p>
         </p:txBody>
       </p:sp>
-      <p:sp>
-        <p:nvSpPr>
-          <p:cNvPr id="6" name="Shape 4"/>
-          <p:cNvSpPr/>
-          <p:nvPr/>
-        </p:nvSpPr>
+      <p:pic>
+        <p:nvPicPr>
+          <p:cNvPr id="6" name="Image 0" descr="/app/applet/src/assets/images/nanobanana_mitigation_engineering_1792124316759.jpg">    </p:cNvPr>
+          <p:cNvPicPr>
+            <a:picLocks noChangeAspect="1"/>
+          </p:cNvPicPr>
+          <p:nvPr/>
+        </p:nvPicPr>
+        <p:blipFill>
+          <a:blip r:embed="rId1"/>
+          <a:stretch>
+            <a:fillRect/>
+          </a:stretch>
+        </p:blipFill>
         <p:spPr>
           <a:xfrm>
             <a:off x="731520" y="1645920"/>
             <a:ext cx="5212080" cy="4389120"/>
           </a:xfrm>
-          <a:prstGeom prst="roundRect">
-            <a:avLst>
-              <a:gd name="adj" fmla="val 2083"/>
-            </a:avLst>
-          </a:prstGeom>
-          <a:solidFill>
-            <a:srgbClr val="1E293B"/>
-          </a:solidFill>
-          <a:ln w="12700">
-            <a:solidFill>
-              <a:srgbClr val="F59E0B"/>
-            </a:solidFill>
-            <a:prstDash val="solid"/>
-          </a:ln>
-        </p:spPr>
-      </p:sp>
-      <p:sp>
-        <p:nvSpPr>
-          <p:cNvPr id="7" name="Text 5"/>
-          <p:cNvSpPr/>
-          <p:nvPr/>
-        </p:nvSpPr>
-        <p:spPr>
-          <a:xfrm>
-            <a:off x="914400" y="1828800"/>
-            <a:ext cx="4846320" cy="365760"/>
-          </a:xfrm>
-          <a:prstGeom prst="rect">
-            <a:avLst/>
-          </a:prstGeom>
-          <a:noFill/>
-          <a:ln/>
-        </p:spPr>
-        <p:txBody>
-          <a:bodyPr wrap="square" rtlCol="0" anchor="ctr"/>
-          <a:lstStyle/>
-          <a:p>
-            <a:pPr indent="0" marL="0">
-              <a:buNone/>
-            </a:pPr>
-            <a:r>
-              <a:rPr lang="en-US" sz="1400" b="1" dirty="0">
-                <a:solidFill>
-                  <a:srgbClr val="F59E0B"/>
-                </a:solidFill>
-              </a:rPr>
-              <a:t>ACTIONABLE STRUCTURAL LEVERS</a:t>
-            </a:r>
-            <a:endParaRPr lang="en-US" sz="1400" dirty="0"/>
-          </a:p>
-        </p:txBody>
-      </p:sp>
-      <p:sp>
-        <p:nvSpPr>
-          <p:cNvPr id="8" name="Text 6"/>
-          <p:cNvSpPr/>
-          <p:nvPr/>
-        </p:nvSpPr>
-        <p:spPr>
-          <a:xfrm>
-            <a:off x="914400" y="2377440"/>
-            <a:ext cx="4846320" cy="3291840"/>
-          </a:xfrm>
-          <a:prstGeom prst="rect">
-            <a:avLst/>
-          </a:prstGeom>
-          <a:noFill/>
-          <a:ln/>
-        </p:spPr>
-        <p:txBody>
-          <a:bodyPr wrap="square" rtlCol="0" anchor="ctr"/>
-          <a:lstStyle/>
-          <a:p>
-            <a:pPr indent="0" marL="0">
-              <a:buNone/>
-            </a:pPr>
-            <a:r>
-              <a:rPr lang="en-US" sz="1200" dirty="0">
-                <a:solidFill>
-                  <a:srgbClr val="F8FAFC"/>
-                </a:solidFill>
-              </a:rPr>
-              <a:t>1. Fasten 2.5kN Ratchet Straps (래칫 벨트 체결)</a:t>
-            </a:r>
-            <a:endParaRPr lang="en-US" sz="1200" dirty="0"/>
-          </a:p>
-          <a:p>
-            <a:pPr indent="0" marL="0">
-              <a:buNone/>
-            </a:pPr>
-            <a:r>
-              <a:rPr lang="en-US" sz="1200" dirty="0">
-                <a:solidFill>
-                  <a:srgbClr val="F8FAFC"/>
-                </a:solidFill>
-              </a:rPr>
-              <a:t>2. Install Rubber Anti-Slip Pads (고무 패드 시공, μ = 0.65)</a:t>
-            </a:r>
-            <a:endParaRPr lang="en-US" sz="1200" dirty="0"/>
-          </a:p>
-          <a:p>
-            <a:pPr indent="0" marL="0">
-              <a:buNone/>
-            </a:pPr>
-            <a:r>
-              <a:rPr lang="en-US" sz="1200" dirty="0">
-                <a:solidFill>
-                  <a:srgbClr val="F8FAFC"/>
-                </a:solidFill>
-              </a:rPr>
-              <a:t>3. Reduce Cargo Stacking by 1 Tier (적재단수 감축)</a:t>
-            </a:r>
-            <a:endParaRPr lang="en-US" sz="1200" dirty="0"/>
-          </a:p>
-          <a:p>
-            <a:pPr indent="0" marL="0">
-              <a:buNone/>
-            </a:pPr>
-            <a:r>
-              <a:rPr lang="en-US" sz="1200" dirty="0">
-                <a:solidFill>
-                  <a:srgbClr val="F8FAFC"/>
-                </a:solidFill>
-              </a:rPr>
-              <a:t>4. Widen Dunnage Base to 1.2m (받침목 지지폭 확장)</a:t>
-            </a:r>
-            <a:endParaRPr lang="en-US" sz="1200" dirty="0"/>
-          </a:p>
-          <a:p>
-            <a:pPr indent="0" marL="0">
-              <a:buNone/>
-            </a:pPr>
-            <a:r>
-              <a:rPr lang="en-US" sz="1200" dirty="0">
-                <a:solidFill>
-                  <a:srgbClr val="F8FAFC"/>
-                </a:solidFill>
-              </a:rPr>
-              <a:t>5. Move Cargo &gt;= 2.8m Inward from Slab Edge (단부 이격)</a:t>
-            </a:r>
-            <a:endParaRPr lang="en-US" sz="1200" dirty="0"/>
-          </a:p>
-          <a:p>
-            <a:pPr indent="0" marL="0">
-              <a:buNone/>
-            </a:pPr>
-            <a:r>
-              <a:rPr lang="en-US" sz="1200" dirty="0">
-                <a:solidFill>
-                  <a:srgbClr val="F8FAFC"/>
-                </a:solidFill>
-              </a:rPr>
-              <a:t>6. Install Windbreak Netting (방풍망 결속)</a:t>
-            </a:r>
-            <a:endParaRPr lang="en-US" sz="1200" dirty="0"/>
-          </a:p>
-        </p:txBody>
-      </p:sp>
-      <p:sp>
-        <p:nvSpPr>
-          <p:cNvPr id="9" name="Shape 7"/>
+          <a:prstGeom prst="ellipse">
+            <a:avLst/>
+          </a:prstGeom>
+        </p:spPr>
+      </p:pic>
+      <p:sp>
+        <p:nvSpPr>
+          <p:cNvPr id="7" name="Shape 4"/>
           <p:cNvSpPr/>
           <p:nvPr/>
         </p:nvSpPr>
@@ -3384,7 +3263,7 @@
       </p:sp>
       <p:sp>
         <p:nvSpPr>
-          <p:cNvPr id="10" name="Text 8"/>
+          <p:cNvPr id="8" name="Text 5"/>
           <p:cNvSpPr/>
           <p:nvPr/>
         </p:nvSpPr>
@@ -3420,7 +3299,7 @@
       </p:sp>
       <p:sp>
         <p:nvSpPr>
-          <p:cNvPr id="11" name="Text 9"/>
+          <p:cNvPr id="9" name="Text 6"/>
           <p:cNvSpPr/>
           <p:nvPr/>
         </p:nvSpPr>
@@ -7444,150 +7323,33 @@
           </a:p>
         </p:txBody>
       </p:sp>
-      <p:sp>
-        <p:nvSpPr>
-          <p:cNvPr id="6" name="Shape 4"/>
-          <p:cNvSpPr/>
-          <p:nvPr/>
-        </p:nvSpPr>
+      <p:pic>
+        <p:nvPicPr>
+          <p:cNvPr id="6" name="Image 0" descr="/app/applet/src/assets/images/aerodynamic_wind_tunnel_1792118019118.jpg">    </p:cNvPr>
+          <p:cNvPicPr>
+            <a:picLocks noChangeAspect="1"/>
+          </p:cNvPicPr>
+          <p:nvPr/>
+        </p:nvPicPr>
+        <p:blipFill>
+          <a:blip r:embed="rId1"/>
+          <a:stretch>
+            <a:fillRect/>
+          </a:stretch>
+        </p:blipFill>
         <p:spPr>
           <a:xfrm>
             <a:off x="731520" y="1645920"/>
             <a:ext cx="5212080" cy="4389120"/>
           </a:xfrm>
-          <a:prstGeom prst="roundRect">
-            <a:avLst>
-              <a:gd name="adj" fmla="val 2083"/>
-            </a:avLst>
-          </a:prstGeom>
-          <a:solidFill>
-            <a:srgbClr val="1E293B"/>
-          </a:solidFill>
-          <a:ln w="12700">
-            <a:solidFill>
-              <a:srgbClr val="06B6D4"/>
-            </a:solidFill>
-            <a:prstDash val="solid"/>
-          </a:ln>
-        </p:spPr>
-      </p:sp>
-      <p:sp>
-        <p:nvSpPr>
-          <p:cNvPr id="7" name="Text 5"/>
-          <p:cNvSpPr/>
-          <p:nvPr/>
-        </p:nvSpPr>
-        <p:spPr>
-          <a:xfrm>
-            <a:off x="914400" y="1828800"/>
-            <a:ext cx="4846320" cy="365760"/>
-          </a:xfrm>
-          <a:prstGeom prst="rect">
-            <a:avLst/>
-          </a:prstGeom>
-          <a:noFill/>
-          <a:ln/>
-        </p:spPr>
-        <p:txBody>
-          <a:bodyPr wrap="square" rtlCol="0" anchor="ctr"/>
-          <a:lstStyle/>
-          <a:p>
-            <a:pPr indent="0" marL="0">
-              <a:buNone/>
-            </a:pPr>
-            <a:r>
-              <a:rPr lang="en-US" sz="1400" b="1" dirty="0">
-                <a:solidFill>
-                  <a:srgbClr val="06B6D4"/>
-                </a:solidFill>
-              </a:rPr>
-              <a:t>CFD SIMULATION ASSETS INTEGRATION</a:t>
-            </a:r>
-            <a:endParaRPr lang="en-US" sz="1400" dirty="0"/>
-          </a:p>
-        </p:txBody>
-      </p:sp>
-      <p:sp>
-        <p:nvSpPr>
-          <p:cNvPr id="8" name="Text 6"/>
-          <p:cNvSpPr/>
-          <p:nvPr/>
-        </p:nvSpPr>
-        <p:spPr>
-          <a:xfrm>
-            <a:off x="914400" y="2377440"/>
-            <a:ext cx="4846320" cy="3291840"/>
-          </a:xfrm>
-          <a:prstGeom prst="rect">
-            <a:avLst/>
-          </a:prstGeom>
-          <a:noFill/>
-          <a:ln/>
-        </p:spPr>
-        <p:txBody>
-          <a:bodyPr wrap="square" rtlCol="0" anchor="ctr"/>
-          <a:lstStyle/>
-          <a:p>
-            <a:pPr indent="0" marL="0">
-              <a:buNone/>
-            </a:pPr>
-            <a:r>
-              <a:rPr lang="en-US" sz="1200" dirty="0">
-                <a:solidFill>
-                  <a:srgbClr val="F8FAFC"/>
-                </a:solidFill>
-              </a:rPr>
-              <a:t>• High-fidelity 3D flow streamlines showing stagnation zones on windward faces.</a:t>
-            </a:r>
-            <a:endParaRPr lang="en-US" sz="1200" dirty="0"/>
-          </a:p>
-          <a:p>
-            <a:pPr indent="0" marL="0">
-              <a:buNone/>
-            </a:pPr>
-            <a:r>
-              <a:rPr lang="en-US" sz="1200" dirty="0">
-                <a:solidFill>
-                  <a:srgbClr val="F8FAFC"/>
-                </a:solidFill>
-              </a:rPr>
-              <a:t>• Recirculating turbulent wake eddies formed behind stacked cargo.</a:t>
-            </a:r>
-            <a:endParaRPr lang="en-US" sz="1200" dirty="0"/>
-          </a:p>
-          <a:p>
-            <a:pPr indent="0" marL="0">
-              <a:buNone/>
-            </a:pPr>
-            <a:r>
-              <a:rPr lang="en-US" sz="1200" dirty="0">
-                <a:solidFill>
-                  <a:srgbClr val="F8FAFC"/>
-                </a:solidFill>
-              </a:rPr>
-              <a:t>• Edge detachment zones illustrating localized negative pressure spikes.</a:t>
-            </a:r>
-            <a:endParaRPr lang="en-US" sz="1200" dirty="0"/>
-          </a:p>
-          <a:p>
-            <a:pPr indent="0" marL="0">
-              <a:buNone/>
-            </a:pPr>
-            <a:r>
-              <a:rPr lang="en-US" sz="1200" dirty="0">
-                <a:solidFill>
-                  <a:srgbClr val="F8FAFC"/>
-                </a:solidFill>
-              </a:rPr>
-              <a:t>• Instant calculation of boundary layer separation points across pallets.</a:t>
-            </a:r>
-            <a:endParaRPr lang="en-US" sz="1200" dirty="0"/>
-          </a:p>
-        </p:txBody>
-      </p:sp>
-      <p:sp>
-        <p:nvSpPr>
-          <p:cNvPr id="9" name="Shape 7"/>
+          <a:prstGeom prst="ellipse">
+            <a:avLst/>
+          </a:prstGeom>
+        </p:spPr>
+      </p:pic>
+      <p:sp>
+        <p:nvSpPr>
+          <p:cNvPr id="7" name="Shape 4"/>
           <p:cNvSpPr/>
           <p:nvPr/>
         </p:nvSpPr>
@@ -7614,7 +7376,7 @@
       </p:sp>
       <p:sp>
         <p:nvSpPr>
-          <p:cNvPr id="10" name="Text 8"/>
+          <p:cNvPr id="8" name="Text 5"/>
           <p:cNvSpPr/>
           <p:nvPr/>
         </p:nvSpPr>
@@ -7650,7 +7412,7 @@
       </p:sp>
       <p:sp>
         <p:nvSpPr>
-          <p:cNvPr id="11" name="Text 9"/>
+          <p:cNvPr id="9" name="Text 6"/>
           <p:cNvSpPr/>
           <p:nvPr/>
         </p:nvSpPr>
@@ -9145,150 +8907,33 @@
           </a:p>
         </p:txBody>
       </p:sp>
-      <p:sp>
-        <p:nvSpPr>
-          <p:cNvPr id="6" name="Shape 4"/>
-          <p:cNvSpPr/>
-          <p:nvPr/>
-        </p:nvSpPr>
+      <p:pic>
+        <p:nvPicPr>
+          <p:cNvPr id="6" name="Image 0" descr="/app/applet/src/assets/images/nanobanana_mobile_patrol_1792124316883.jpg">    </p:cNvPr>
+          <p:cNvPicPr>
+            <a:picLocks noChangeAspect="1"/>
+          </p:cNvPicPr>
+          <p:nvPr/>
+        </p:nvPicPr>
+        <p:blipFill>
+          <a:blip r:embed="rId1"/>
+          <a:stretch>
+            <a:fillRect/>
+          </a:stretch>
+        </p:blipFill>
         <p:spPr>
           <a:xfrm>
             <a:off x="731520" y="1645920"/>
             <a:ext cx="5212080" cy="4389120"/>
           </a:xfrm>
-          <a:prstGeom prst="roundRect">
-            <a:avLst>
-              <a:gd name="adj" fmla="val 2083"/>
-            </a:avLst>
-          </a:prstGeom>
-          <a:solidFill>
-            <a:srgbClr val="1E293B"/>
-          </a:solidFill>
-          <a:ln w="12700">
-            <a:solidFill>
-              <a:srgbClr val="F59E0B"/>
-            </a:solidFill>
-            <a:prstDash val="solid"/>
-          </a:ln>
-        </p:spPr>
-      </p:sp>
-      <p:sp>
-        <p:nvSpPr>
-          <p:cNvPr id="7" name="Text 5"/>
-          <p:cNvSpPr/>
-          <p:nvPr/>
-        </p:nvSpPr>
-        <p:spPr>
-          <a:xfrm>
-            <a:off x="914400" y="1828800"/>
-            <a:ext cx="4846320" cy="365760"/>
-          </a:xfrm>
-          <a:prstGeom prst="rect">
-            <a:avLst/>
-          </a:prstGeom>
-          <a:noFill/>
-          <a:ln/>
-        </p:spPr>
-        <p:txBody>
-          <a:bodyPr wrap="square" rtlCol="0" anchor="ctr"/>
-          <a:lstStyle/>
-          <a:p>
-            <a:pPr indent="0" marL="0">
-              <a:buNone/>
-            </a:pPr>
-            <a:r>
-              <a:rPr lang="en-US" sz="1400" b="1" dirty="0">
-                <a:solidFill>
-                  <a:srgbClr val="F59E0B"/>
-                </a:solidFill>
-              </a:rPr>
-              <a:t>1-HANDED SMARTPHONE OPTIMIZATION</a:t>
-            </a:r>
-            <a:endParaRPr lang="en-US" sz="1400" dirty="0"/>
-          </a:p>
-        </p:txBody>
-      </p:sp>
-      <p:sp>
-        <p:nvSpPr>
-          <p:cNvPr id="8" name="Text 6"/>
-          <p:cNvSpPr/>
-          <p:nvPr/>
-        </p:nvSpPr>
-        <p:spPr>
-          <a:xfrm>
-            <a:off x="914400" y="2377440"/>
-            <a:ext cx="4846320" cy="3291840"/>
-          </a:xfrm>
-          <a:prstGeom prst="rect">
-            <a:avLst/>
-          </a:prstGeom>
-          <a:noFill/>
-          <a:ln/>
-        </p:spPr>
-        <p:txBody>
-          <a:bodyPr wrap="square" rtlCol="0" anchor="ctr"/>
-          <a:lstStyle/>
-          <a:p>
-            <a:pPr indent="0" marL="0">
-              <a:buNone/>
-            </a:pPr>
-            <a:r>
-              <a:rPr lang="en-US" sz="1200" dirty="0">
-                <a:solidFill>
-                  <a:srgbClr val="F8FAFC"/>
-                </a:solidFill>
-              </a:rPr>
-              <a:t>• High outdoor contrast, large touch targets, zero UI overflow.</a:t>
-            </a:r>
-            <a:endParaRPr lang="en-US" sz="1200" dirty="0"/>
-          </a:p>
-          <a:p>
-            <a:pPr indent="0" marL="0">
-              <a:buNone/>
-            </a:pPr>
-            <a:r>
-              <a:rPr lang="en-US" sz="1200" dirty="0">
-                <a:solidFill>
-                  <a:srgbClr val="F8FAFC"/>
-                </a:solidFill>
-              </a:rPr>
-              <a:t>• Plain-Language Dimensions: Replaced raw LWH with '2.0m width · 1.0m length (10cm thick)'.</a:t>
-            </a:r>
-            <a:endParaRPr lang="en-US" sz="1200" dirty="0"/>
-          </a:p>
-          <a:p>
-            <a:pPr indent="0" marL="0">
-              <a:buNone/>
-            </a:pPr>
-            <a:r>
-              <a:rPr lang="en-US" sz="1200" dirty="0">
-                <a:solidFill>
-                  <a:srgbClr val="F8FAFC"/>
-                </a:solidFill>
-              </a:rPr>
-              <a:t>• Tap-to-Expand Accordion: Tapping any card immediately expands its 5 individual physics metrics in-place.</a:t>
-            </a:r>
-            <a:endParaRPr lang="en-US" sz="1200" dirty="0"/>
-          </a:p>
-          <a:p>
-            <a:pPr indent="0" marL="0">
-              <a:buNone/>
-            </a:pPr>
-            <a:r>
-              <a:rPr lang="en-US" sz="1200" dirty="0">
-                <a:solidFill>
-                  <a:srgbClr val="F8FAFC"/>
-                </a:solidFill>
-              </a:rPr>
-              <a:t>• 1-Touch Ratchet Toggle: Instant color feedback (amber unstrapped &lt;-&gt; emerald 3.5kN secured) with instant recalculation.</a:t>
-            </a:r>
-            <a:endParaRPr lang="en-US" sz="1200" dirty="0"/>
-          </a:p>
-        </p:txBody>
-      </p:sp>
-      <p:sp>
-        <p:nvSpPr>
-          <p:cNvPr id="9" name="Shape 7"/>
+          <a:prstGeom prst="ellipse">
+            <a:avLst/>
+          </a:prstGeom>
+        </p:spPr>
+      </p:pic>
+      <p:sp>
+        <p:nvSpPr>
+          <p:cNvPr id="7" name="Shape 4"/>
           <p:cNvSpPr/>
           <p:nvPr/>
         </p:nvSpPr>
@@ -9315,7 +8960,7 @@
       </p:sp>
       <p:sp>
         <p:nvSpPr>
-          <p:cNvPr id="10" name="Text 8"/>
+          <p:cNvPr id="8" name="Text 5"/>
           <p:cNvSpPr/>
           <p:nvPr/>
         </p:nvSpPr>
@@ -9351,7 +8996,7 @@
       </p:sp>
       <p:sp>
         <p:nvSpPr>
-          <p:cNvPr id="11" name="Text 9"/>
+          <p:cNvPr id="9" name="Text 6"/>
           <p:cNvSpPr/>
           <p:nvPr/>
         </p:nvSpPr>

</xml_diff>